<commit_message>
update diagramme avec fleche verte
</commit_message>
<xml_diff>
--- a/LPHY1365/correction_structure.pptx
+++ b/LPHY1365/correction_structure.pptx
@@ -198,7 +198,7 @@
           <a:p>
             <a:fld id="{1290E4CE-CCAD-4149-AC2B-FD051B57DC65}" type="datetimeFigureOut">
               <a:rPr lang="fr-FR" smtClean="0"/>
-              <a:t>18/03/2026</a:t>
+              <a:t>19/03/2026</a:t>
             </a:fld>
             <a:endParaRPr lang="fr-FR"/>
           </a:p>
@@ -696,7 +696,7 @@
           <a:p>
             <a:fld id="{F2379CAC-48ED-AD47-B367-92FBB37E46BE}" type="datetimeFigureOut">
               <a:rPr lang="fr-FR" smtClean="0"/>
-              <a:t>18/03/2026</a:t>
+              <a:t>19/03/2026</a:t>
             </a:fld>
             <a:endParaRPr lang="fr-FR"/>
           </a:p>
@@ -894,7 +894,7 @@
           <a:p>
             <a:fld id="{F2379CAC-48ED-AD47-B367-92FBB37E46BE}" type="datetimeFigureOut">
               <a:rPr lang="fr-FR" smtClean="0"/>
-              <a:t>18/03/2026</a:t>
+              <a:t>19/03/2026</a:t>
             </a:fld>
             <a:endParaRPr lang="fr-FR"/>
           </a:p>
@@ -1102,7 +1102,7 @@
           <a:p>
             <a:fld id="{F2379CAC-48ED-AD47-B367-92FBB37E46BE}" type="datetimeFigureOut">
               <a:rPr lang="fr-FR" smtClean="0"/>
-              <a:t>18/03/2026</a:t>
+              <a:t>19/03/2026</a:t>
             </a:fld>
             <a:endParaRPr lang="fr-FR"/>
           </a:p>
@@ -1300,7 +1300,7 @@
           <a:p>
             <a:fld id="{F2379CAC-48ED-AD47-B367-92FBB37E46BE}" type="datetimeFigureOut">
               <a:rPr lang="fr-FR" smtClean="0"/>
-              <a:t>18/03/2026</a:t>
+              <a:t>19/03/2026</a:t>
             </a:fld>
             <a:endParaRPr lang="fr-FR"/>
           </a:p>
@@ -1575,7 +1575,7 @@
           <a:p>
             <a:fld id="{F2379CAC-48ED-AD47-B367-92FBB37E46BE}" type="datetimeFigureOut">
               <a:rPr lang="fr-FR" smtClean="0"/>
-              <a:t>18/03/2026</a:t>
+              <a:t>19/03/2026</a:t>
             </a:fld>
             <a:endParaRPr lang="fr-FR"/>
           </a:p>
@@ -1840,7 +1840,7 @@
           <a:p>
             <a:fld id="{F2379CAC-48ED-AD47-B367-92FBB37E46BE}" type="datetimeFigureOut">
               <a:rPr lang="fr-FR" smtClean="0"/>
-              <a:t>18/03/2026</a:t>
+              <a:t>19/03/2026</a:t>
             </a:fld>
             <a:endParaRPr lang="fr-FR"/>
           </a:p>
@@ -2252,7 +2252,7 @@
           <a:p>
             <a:fld id="{F2379CAC-48ED-AD47-B367-92FBB37E46BE}" type="datetimeFigureOut">
               <a:rPr lang="fr-FR" smtClean="0"/>
-              <a:t>18/03/2026</a:t>
+              <a:t>19/03/2026</a:t>
             </a:fld>
             <a:endParaRPr lang="fr-FR"/>
           </a:p>
@@ -2393,7 +2393,7 @@
           <a:p>
             <a:fld id="{F2379CAC-48ED-AD47-B367-92FBB37E46BE}" type="datetimeFigureOut">
               <a:rPr lang="fr-FR" smtClean="0"/>
-              <a:t>18/03/2026</a:t>
+              <a:t>19/03/2026</a:t>
             </a:fld>
             <a:endParaRPr lang="fr-FR"/>
           </a:p>
@@ -2506,7 +2506,7 @@
           <a:p>
             <a:fld id="{F2379CAC-48ED-AD47-B367-92FBB37E46BE}" type="datetimeFigureOut">
               <a:rPr lang="fr-FR" smtClean="0"/>
-              <a:t>18/03/2026</a:t>
+              <a:t>19/03/2026</a:t>
             </a:fld>
             <a:endParaRPr lang="fr-FR"/>
           </a:p>
@@ -2817,7 +2817,7 @@
           <a:p>
             <a:fld id="{F2379CAC-48ED-AD47-B367-92FBB37E46BE}" type="datetimeFigureOut">
               <a:rPr lang="fr-FR" smtClean="0"/>
-              <a:t>18/03/2026</a:t>
+              <a:t>19/03/2026</a:t>
             </a:fld>
             <a:endParaRPr lang="fr-FR"/>
           </a:p>
@@ -3105,7 +3105,7 @@
           <a:p>
             <a:fld id="{F2379CAC-48ED-AD47-B367-92FBB37E46BE}" type="datetimeFigureOut">
               <a:rPr lang="fr-FR" smtClean="0"/>
-              <a:t>18/03/2026</a:t>
+              <a:t>19/03/2026</a:t>
             </a:fld>
             <a:endParaRPr lang="fr-FR"/>
           </a:p>
@@ -3346,7 +3346,7 @@
           <a:p>
             <a:fld id="{F2379CAC-48ED-AD47-B367-92FBB37E46BE}" type="datetimeFigureOut">
               <a:rPr lang="fr-FR" smtClean="0"/>
-              <a:t>18/03/2026</a:t>
+              <a:t>19/03/2026</a:t>
             </a:fld>
             <a:endParaRPr lang="fr-FR"/>
           </a:p>
@@ -5963,6 +5963,170 @@
           </a:prstGeom>
         </p:spPr>
       </p:pic>
+      <p:sp>
+        <p:nvSpPr>
+          <p:cNvPr id="2" name="ZoneTexte 1">
+            <a:extLst>
+              <a:ext uri="{FF2B5EF4-FFF2-40B4-BE49-F238E27FC236}">
+                <a16:creationId xmlns:a16="http://schemas.microsoft.com/office/drawing/2014/main" id="{ECA2ABA9-4364-D08D-23D2-324A1AF79BA9}"/>
+              </a:ext>
+            </a:extLst>
+          </p:cNvPr>
+          <p:cNvSpPr txBox="1"/>
+          <p:nvPr/>
+        </p:nvSpPr>
+        <p:spPr>
+          <a:xfrm rot="722635">
+            <a:off x="362640" y="4000128"/>
+            <a:ext cx="918344" cy="276999"/>
+          </a:xfrm>
+          <a:prstGeom prst="rect">
+            <a:avLst/>
+          </a:prstGeom>
+          <a:noFill/>
+        </p:spPr>
+        <p:txBody>
+          <a:bodyPr wrap="square" rtlCol="0">
+            <a:spAutoFit/>
+          </a:bodyPr>
+          <a:lstStyle/>
+          <a:p>
+            <a:r>
+              <a:rPr lang="fr-FR" sz="1200" b="1" dirty="0">
+                <a:solidFill>
+                  <a:srgbClr val="92D050"/>
+                </a:solidFill>
+                <a:latin typeface="Segoe UI Light" panose="020B0502040204020203" pitchFamily="34" charset="0"/>
+                <a:cs typeface="Segoe UI Light" panose="020B0502040204020203" pitchFamily="34" charset="0"/>
+              </a:rPr>
+              <a:t>correction</a:t>
+            </a:r>
+          </a:p>
+        </p:txBody>
+      </p:sp>
+      <p:sp>
+        <p:nvSpPr>
+          <p:cNvPr id="3" name="ZoneTexte 2">
+            <a:extLst>
+              <a:ext uri="{FF2B5EF4-FFF2-40B4-BE49-F238E27FC236}">
+                <a16:creationId xmlns:a16="http://schemas.microsoft.com/office/drawing/2014/main" id="{EA3E548A-D232-3936-4F1D-714F515E3ED6}"/>
+              </a:ext>
+            </a:extLst>
+          </p:cNvPr>
+          <p:cNvSpPr txBox="1"/>
+          <p:nvPr/>
+        </p:nvSpPr>
+        <p:spPr>
+          <a:xfrm rot="722635">
+            <a:off x="2386128" y="4716128"/>
+            <a:ext cx="918344" cy="276999"/>
+          </a:xfrm>
+          <a:prstGeom prst="rect">
+            <a:avLst/>
+          </a:prstGeom>
+          <a:noFill/>
+        </p:spPr>
+        <p:txBody>
+          <a:bodyPr wrap="square" rtlCol="0">
+            <a:spAutoFit/>
+          </a:bodyPr>
+          <a:lstStyle/>
+          <a:p>
+            <a:r>
+              <a:rPr lang="fr-FR" sz="1200" b="1" dirty="0">
+                <a:solidFill>
+                  <a:srgbClr val="92D050"/>
+                </a:solidFill>
+                <a:latin typeface="Segoe UI Light" panose="020B0502040204020203" pitchFamily="34" charset="0"/>
+                <a:cs typeface="Segoe UI Light" panose="020B0502040204020203" pitchFamily="34" charset="0"/>
+              </a:rPr>
+              <a:t>correction</a:t>
+            </a:r>
+          </a:p>
+        </p:txBody>
+      </p:sp>
+      <p:sp>
+        <p:nvSpPr>
+          <p:cNvPr id="11" name="ZoneTexte 10">
+            <a:extLst>
+              <a:ext uri="{FF2B5EF4-FFF2-40B4-BE49-F238E27FC236}">
+                <a16:creationId xmlns:a16="http://schemas.microsoft.com/office/drawing/2014/main" id="{0F7F527E-E772-FAEB-42D5-CB0F5D55130C}"/>
+              </a:ext>
+            </a:extLst>
+          </p:cNvPr>
+          <p:cNvSpPr txBox="1"/>
+          <p:nvPr/>
+        </p:nvSpPr>
+        <p:spPr>
+          <a:xfrm rot="20703686">
+            <a:off x="9407378" y="5497375"/>
+            <a:ext cx="918344" cy="276999"/>
+          </a:xfrm>
+          <a:prstGeom prst="rect">
+            <a:avLst/>
+          </a:prstGeom>
+          <a:noFill/>
+        </p:spPr>
+        <p:txBody>
+          <a:bodyPr wrap="square" rtlCol="0">
+            <a:spAutoFit/>
+          </a:bodyPr>
+          <a:lstStyle/>
+          <a:p>
+            <a:r>
+              <a:rPr lang="fr-FR" sz="1200" b="1" dirty="0">
+                <a:solidFill>
+                  <a:srgbClr val="92D050"/>
+                </a:solidFill>
+                <a:latin typeface="Segoe UI Light" panose="020B0502040204020203" pitchFamily="34" charset="0"/>
+                <a:cs typeface="Segoe UI Light" panose="020B0502040204020203" pitchFamily="34" charset="0"/>
+              </a:rPr>
+              <a:t>correction</a:t>
+            </a:r>
+          </a:p>
+        </p:txBody>
+      </p:sp>
+      <p:sp>
+        <p:nvSpPr>
+          <p:cNvPr id="13" name="ZoneTexte 12">
+            <a:extLst>
+              <a:ext uri="{FF2B5EF4-FFF2-40B4-BE49-F238E27FC236}">
+                <a16:creationId xmlns:a16="http://schemas.microsoft.com/office/drawing/2014/main" id="{8694E7ED-D52A-758C-E7CD-D3D3F9A3BCAD}"/>
+              </a:ext>
+            </a:extLst>
+          </p:cNvPr>
+          <p:cNvSpPr txBox="1"/>
+          <p:nvPr/>
+        </p:nvSpPr>
+        <p:spPr>
+          <a:xfrm rot="20221220">
+            <a:off x="11224782" y="4912278"/>
+            <a:ext cx="918344" cy="276999"/>
+          </a:xfrm>
+          <a:prstGeom prst="rect">
+            <a:avLst/>
+          </a:prstGeom>
+          <a:noFill/>
+        </p:spPr>
+        <p:txBody>
+          <a:bodyPr wrap="square" rtlCol="0">
+            <a:spAutoFit/>
+          </a:bodyPr>
+          <a:lstStyle/>
+          <a:p>
+            <a:r>
+              <a:rPr lang="fr-FR" sz="1200" b="1" dirty="0">
+                <a:solidFill>
+                  <a:srgbClr val="92D050"/>
+                </a:solidFill>
+                <a:latin typeface="Segoe UI Light" panose="020B0502040204020203" pitchFamily="34" charset="0"/>
+                <a:cs typeface="Segoe UI Light" panose="020B0502040204020203" pitchFamily="34" charset="0"/>
+              </a:rPr>
+              <a:t>correction</a:t>
+            </a:r>
+          </a:p>
+        </p:txBody>
+      </p:sp>
     </p:spTree>
     <p:extLst>
       <p:ext uri="{BB962C8B-B14F-4D97-AF65-F5344CB8AC3E}">

</xml_diff>